<commit_message>
Project 1 - Final commit
</commit_message>
<xml_diff>
--- a/Lama-Polyd-Mama- Project1.pptx
+++ b/Lama-Polyd-Mama- Project1.pptx
@@ -14,7 +14,8 @@
     <p:sldId id="262" r:id="rId8"/>
     <p:sldId id="263" r:id="rId9"/>
     <p:sldId id="265" r:id="rId10"/>
-    <p:sldId id="266" r:id="rId11"/>
+    <p:sldId id="269" r:id="rId11"/>
+    <p:sldId id="266" r:id="rId12"/>
   </p:sldIdLst>
   <p:sldSz cx="12192000" cy="6858000"/>
   <p:notesSz cx="6858000" cy="9144000"/>
@@ -113,6 +114,11 @@
       </a:defRPr>
     </a:lvl9pPr>
   </p:defaultTextStyle>
+  <p:extLst>
+    <p:ext uri="{EFAFB233-063F-42B5-8137-9DF3F51BA10A}">
+      <p15:sldGuideLst xmlns:p15="http://schemas.microsoft.com/office/powerpoint/2012/main"/>
+    </p:ext>
+  </p:extLst>
 </p:presentation>
 </file>
 
@@ -3478,6 +3484,147 @@
           <p:cNvPr id="2" name="Title 1">
             <a:extLst>
               <a:ext uri="{FF2B5EF4-FFF2-40B4-BE49-F238E27FC236}">
+                <a16:creationId xmlns:a16="http://schemas.microsoft.com/office/drawing/2014/main" id="{E1CAA489-9F35-88DA-6AA6-64473CA6280C}"/>
+              </a:ext>
+            </a:extLst>
+          </p:cNvPr>
+          <p:cNvSpPr>
+            <a:spLocks noGrp="1"/>
+          </p:cNvSpPr>
+          <p:nvPr>
+            <p:ph type="title"/>
+          </p:nvPr>
+        </p:nvSpPr>
+        <p:spPr/>
+        <p:txBody>
+          <a:bodyPr/>
+          <a:lstStyle/>
+          <a:p>
+            <a:r>
+              <a:rPr lang="en-US" dirty="0"/>
+              <a:t>RFM analysis attempt failed</a:t>
+            </a:r>
+            <a:endParaRPr lang="el-GR" dirty="0"/>
+          </a:p>
+        </p:txBody>
+      </p:sp>
+      <p:sp>
+        <p:nvSpPr>
+          <p:cNvPr id="3" name="Content Placeholder 2">
+            <a:extLst>
+              <a:ext uri="{FF2B5EF4-FFF2-40B4-BE49-F238E27FC236}">
+                <a16:creationId xmlns:a16="http://schemas.microsoft.com/office/drawing/2014/main" id="{4EF672E5-7734-68CC-D39A-9192327CA8AC}"/>
+              </a:ext>
+            </a:extLst>
+          </p:cNvPr>
+          <p:cNvSpPr>
+            <a:spLocks noGrp="1"/>
+          </p:cNvSpPr>
+          <p:nvPr>
+            <p:ph idx="1"/>
+          </p:nvPr>
+        </p:nvSpPr>
+        <p:spPr/>
+        <p:txBody>
+          <a:bodyPr/>
+          <a:lstStyle/>
+          <a:p>
+            <a:r>
+              <a:rPr lang="en-US" dirty="0"/>
+              <a:t>More completed Data needed</a:t>
+            </a:r>
+          </a:p>
+          <a:p>
+            <a:r>
+              <a:rPr lang="en-US" dirty="0"/>
+              <a:t>Attempt to perform an RFM analysis failed</a:t>
+            </a:r>
+          </a:p>
+          <a:p>
+            <a:pPr lvl="1"/>
+            <a:r>
+              <a:rPr lang="en-US" dirty="0"/>
+              <a:t>Due to Data limitations</a:t>
+            </a:r>
+          </a:p>
+          <a:p>
+            <a:pPr lvl="1"/>
+            <a:r>
+              <a:rPr lang="en-US" dirty="0"/>
+              <a:t>70% of customers had only one order</a:t>
+            </a:r>
+          </a:p>
+          <a:p>
+            <a:pPr lvl="2"/>
+            <a:r>
+              <a:rPr lang="en-US" dirty="0"/>
+              <a:t>Impossible to distribute in bins</a:t>
+            </a:r>
+          </a:p>
+          <a:p>
+            <a:pPr lvl="2"/>
+            <a:r>
+              <a:rPr lang="en-US" dirty="0"/>
+              <a:t>Frequency analysis failed</a:t>
+            </a:r>
+          </a:p>
+          <a:p>
+            <a:r>
+              <a:rPr lang="en-US" dirty="0"/>
+              <a:t>RFM analysis</a:t>
+            </a:r>
+          </a:p>
+          <a:p>
+            <a:pPr lvl="1"/>
+            <a:r>
+              <a:rPr lang="en-US" dirty="0"/>
+              <a:t>rather inappropriate for Amazon orders</a:t>
+            </a:r>
+          </a:p>
+          <a:p>
+            <a:pPr lvl="1"/>
+            <a:r>
+              <a:rPr lang="en-US" dirty="0"/>
+              <a:t>Only if additional data demonstrate more than one purchase per customer</a:t>
+            </a:r>
+          </a:p>
+        </p:txBody>
+      </p:sp>
+    </p:spTree>
+    <p:extLst>
+      <p:ext uri="{BB962C8B-B14F-4D97-AF65-F5344CB8AC3E}">
+        <p14:creationId xmlns:p14="http://schemas.microsoft.com/office/powerpoint/2010/main" val="3457755821"/>
+      </p:ext>
+    </p:extLst>
+  </p:cSld>
+  <p:clrMapOvr>
+    <a:masterClrMapping/>
+  </p:clrMapOvr>
+</p:sld>
+</file>
+
+<file path=ppt/slides/slide11.xml><?xml version="1.0" encoding="utf-8"?>
+<p:sld xmlns:a="http://schemas.openxmlformats.org/drawingml/2006/main" xmlns:r="http://schemas.openxmlformats.org/officeDocument/2006/relationships" xmlns:p="http://schemas.openxmlformats.org/presentationml/2006/main">
+  <p:cSld>
+    <p:spTree>
+      <p:nvGrpSpPr>
+        <p:cNvPr id="1" name=""/>
+        <p:cNvGrpSpPr/>
+        <p:nvPr/>
+      </p:nvGrpSpPr>
+      <p:grpSpPr>
+        <a:xfrm>
+          <a:off x="0" y="0"/>
+          <a:ext cx="0" cy="0"/>
+          <a:chOff x="0" y="0"/>
+          <a:chExt cx="0" cy="0"/>
+        </a:xfrm>
+      </p:grpSpPr>
+      <p:sp>
+        <p:nvSpPr>
+          <p:cNvPr id="2" name="Title 1">
+            <a:extLst>
+              <a:ext uri="{FF2B5EF4-FFF2-40B4-BE49-F238E27FC236}">
                 <a16:creationId xmlns:a16="http://schemas.microsoft.com/office/drawing/2014/main" id="{86660030-C10A-38D3-53EB-646E3718A1D7}"/>
               </a:ext>
             </a:extLst>
@@ -5375,10 +5522,10 @@
       </p:sp>
       <p:graphicFrame>
         <p:nvGraphicFramePr>
-          <p:cNvPr id="9" name="Object 8">
-            <a:extLst>
-              <a:ext uri="{FF2B5EF4-FFF2-40B4-BE49-F238E27FC236}">
-                <a16:creationId xmlns:a16="http://schemas.microsoft.com/office/drawing/2014/main" id="{ABC0974B-F903-886A-357B-117FD4FA4220}"/>
+          <p:cNvPr id="4" name="Object 3">
+            <a:extLst>
+              <a:ext uri="{FF2B5EF4-FFF2-40B4-BE49-F238E27FC236}">
+                <a16:creationId xmlns:a16="http://schemas.microsoft.com/office/drawing/2014/main" id="{6D39CC00-F562-7FD6-F36A-ACE159AF608E}"/>
               </a:ext>
             </a:extLst>
           </p:cNvPr>
@@ -5388,13 +5535,13 @@
           <p:nvPr>
             <p:extLst>
               <p:ext uri="{D42A27DB-BD31-4B8C-83A1-F6EECF244321}">
-                <p14:modId xmlns:p14="http://schemas.microsoft.com/office/powerpoint/2010/main" val="1660238262"/>
+                <p14:modId xmlns:p14="http://schemas.microsoft.com/office/powerpoint/2010/main" val="862438611"/>
               </p:ext>
             </p:extLst>
           </p:nvPr>
         </p:nvGraphicFramePr>
         <p:xfrm>
-          <a:off x="4736592" y="390525"/>
+          <a:off x="4897755" y="390525"/>
           <a:ext cx="4133850" cy="6076950"/>
         </p:xfrm>
         <a:graphic>
@@ -5422,7 +5569,7 @@
                     </p:blipFill>
                     <p:spPr>
                       <a:xfrm>
-                        <a:off x="4736592" y="390525"/>
+                        <a:off x="4897755" y="390525"/>
                         <a:ext cx="4133850" cy="6076950"/>
                       </a:xfrm>
                       <a:prstGeom prst="rect">
@@ -5930,7 +6077,7 @@
             <a:pPr lvl="1"/>
             <a:r>
               <a:rPr lang="en-US" dirty="0"/>
-              <a:t>Boost sales in week countries / categories</a:t>
+              <a:t>Boost sales in weak countries / categories</a:t>
             </a:r>
           </a:p>
           <a:p>

</xml_diff>